<commit_message>
updating course plan, project, asgs
</commit_message>
<xml_diff>
--- a/slides/Project.pptx
+++ b/slides/Project.pptx
@@ -271,7 +271,7 @@
               <a:pPr>
                 <a:defRPr/>
               </a:pPr>
-              <a:t>13-04-2025</a:t>
+              <a:t>20-03-2026</a:t>
             </a:fld>
             <a:endParaRPr lang="en-US"/>
           </a:p>
@@ -793,7 +793,7 @@
               <a:pPr>
                 <a:defRPr/>
               </a:pPr>
-              <a:t>13-04-2025</a:t>
+              <a:t>20-03-2026</a:t>
             </a:fld>
             <a:endParaRPr lang="en-US"/>
           </a:p>
@@ -983,7 +983,7 @@
               <a:pPr>
                 <a:defRPr/>
               </a:pPr>
-              <a:t>13-04-2025</a:t>
+              <a:t>20-03-2026</a:t>
             </a:fld>
             <a:endParaRPr lang="en-US"/>
           </a:p>
@@ -1183,7 +1183,7 @@
               <a:pPr>
                 <a:defRPr/>
               </a:pPr>
-              <a:t>13-04-2025</a:t>
+              <a:t>20-03-2026</a:t>
             </a:fld>
             <a:endParaRPr lang="en-US"/>
           </a:p>
@@ -1379,7 +1379,7 @@
               <a:pPr>
                 <a:defRPr/>
               </a:pPr>
-              <a:t>13-04-2025</a:t>
+              <a:t>20-03-2026</a:t>
             </a:fld>
             <a:endParaRPr lang="en-US"/>
           </a:p>
@@ -1646,7 +1646,7 @@
               <a:pPr>
                 <a:defRPr/>
               </a:pPr>
-              <a:t>13-04-2025</a:t>
+              <a:t>20-03-2026</a:t>
             </a:fld>
             <a:endParaRPr lang="en-US"/>
           </a:p>
@@ -1953,7 +1953,7 @@
               <a:pPr>
                 <a:defRPr/>
               </a:pPr>
-              <a:t>13-04-2025</a:t>
+              <a:t>20-03-2026</a:t>
             </a:fld>
             <a:endParaRPr lang="en-US"/>
           </a:p>
@@ -2394,7 +2394,7 @@
               <a:pPr>
                 <a:defRPr/>
               </a:pPr>
-              <a:t>13-04-2025</a:t>
+              <a:t>20-03-2026</a:t>
             </a:fld>
             <a:endParaRPr lang="en-US"/>
           </a:p>
@@ -2533,7 +2533,7 @@
               <a:pPr>
                 <a:defRPr/>
               </a:pPr>
-              <a:t>13-04-2025</a:t>
+              <a:t>20-03-2026</a:t>
             </a:fld>
             <a:endParaRPr lang="en-US"/>
           </a:p>
@@ -2650,7 +2650,7 @@
               <a:pPr>
                 <a:defRPr/>
               </a:pPr>
-              <a:t>13-04-2025</a:t>
+              <a:t>20-03-2026</a:t>
             </a:fld>
             <a:endParaRPr lang="en-US"/>
           </a:p>
@@ -2947,7 +2947,7 @@
               <a:pPr>
                 <a:defRPr/>
               </a:pPr>
-              <a:t>13-04-2025</a:t>
+              <a:t>20-03-2026</a:t>
             </a:fld>
             <a:endParaRPr lang="en-US"/>
           </a:p>
@@ -3224,7 +3224,7 @@
               <a:pPr>
                 <a:defRPr/>
               </a:pPr>
-              <a:t>13-04-2025</a:t>
+              <a:t>20-03-2026</a:t>
             </a:fld>
             <a:endParaRPr lang="en-US"/>
           </a:p>
@@ -3480,7 +3480,7 @@
               <a:pPr>
                 <a:defRPr/>
               </a:pPr>
-              <a:t>13-04-2025</a:t>
+              <a:t>20-03-2026</a:t>
             </a:fld>
             <a:endParaRPr lang="en-US"/>
           </a:p>
@@ -4079,7 +4079,7 @@
             </a:pPr>
             <a:r>
               <a:rPr lang="en-US" sz="2800" dirty="0"/>
-              <a:t>2023/24</a:t>
+              <a:t>2025/26</a:t>
             </a:r>
           </a:p>
           <a:p>
@@ -4322,28 +4322,28 @@
           <a:lstStyle/>
           <a:p>
             <a:r>
-              <a:rPr lang="en-NL"/>
+              <a:rPr lang="en-NL" dirty="0"/>
               <a:t>Single player</a:t>
             </a:r>
           </a:p>
           <a:p>
             <a:r>
-              <a:rPr lang="en-NL"/>
+              <a:rPr lang="en-NL" dirty="0"/>
               <a:t>Turn-based (so... </a:t>
             </a:r>
             <a:r>
-              <a:rPr lang="en-GB"/>
+              <a:rPr lang="en-GB" dirty="0"/>
               <a:t>n</a:t>
             </a:r>
             <a:r>
-              <a:rPr lang="en-NL"/>
+              <a:rPr lang="en-NL" dirty="0"/>
               <a:t>ot real time)</a:t>
             </a:r>
           </a:p>
           <a:p>
             <a:r>
-              <a:rPr lang="en-NL"/>
-              <a:t>Console-based application</a:t>
+              <a:rPr lang="en-NL" dirty="0"/>
+              <a:t>Command-line-based application</a:t>
             </a:r>
           </a:p>
         </p:txBody>

</xml_diff>